<commit_message>
Deck: fix team-slide framing, add creator profile pic on reveal
</commit_message>
<xml_diff>
--- a/TrackC-Pitch.pptx
+++ b/TrackC-Pitch.pptx
@@ -2115,73 +2115,97 @@
       </p:pic>
       <p:sp>
         <p:nvSpPr>
-          <p:cNvPr id="3" name="Shape 0"/>
-          <p:cNvSpPr/>
-          <p:nvPr/>
-        </p:nvSpPr>
-        <p:spPr>
-          <a:xfrm>
-            <a:off x="6949440" y="0"/>
-            <a:ext cx="5239512" cy="6858000"/>
-          </a:xfrm>
-          <a:prstGeom prst="rect">
+          <p:cNvPr id="3" name="Text 0"/>
+          <p:cNvSpPr/>
+          <p:nvPr/>
+        </p:nvSpPr>
+        <p:spPr>
+          <a:xfrm>
+            <a:off x="7269480" y="914400"/>
+            <a:ext cx="5486400" cy="274320"/>
+          </a:xfrm>
+          <a:prstGeom prst="rect">
+            <a:avLst/>
+          </a:prstGeom>
+          <a:noFill/>
+          <a:ln/>
+        </p:spPr>
+        <p:txBody>
+          <a:bodyPr wrap="square" lIns="0" tIns="0" rIns="0" bIns="0" rtlCol="0" anchor="ctr"/>
+          <a:lstStyle/>
+          <a:p>
+            <a:pPr indent="0" marL="0">
+              <a:buNone/>
+            </a:pPr>
+            <a:r>
+              <a:rPr lang="en-US" sz="1100" b="1" spc="300" kern="0" dirty="0">
+                <a:solidFill>
+                  <a:srgbClr val="38BDF8"/>
+                </a:solidFill>
+                <a:latin typeface="Arial" pitchFamily="34" charset="0"/>
+                <a:ea typeface="Arial" pitchFamily="34" charset="-122"/>
+                <a:cs typeface="Arial" pitchFamily="34" charset="-120"/>
+              </a:rPr>
+              <a:t>AND ONE MORE THING</a:t>
+            </a:r>
+            <a:endParaRPr lang="en-US" sz="1100" dirty="0"/>
+          </a:p>
+        </p:txBody>
+      </p:sp>
+      <p:sp>
+        <p:nvSpPr>
+          <p:cNvPr id="4" name="Shape 1"/>
+          <p:cNvSpPr/>
+          <p:nvPr/>
+        </p:nvSpPr>
+        <p:spPr>
+          <a:xfrm>
+            <a:off x="7205472" y="1298448"/>
+            <a:ext cx="1591056" cy="1591056"/>
+          </a:xfrm>
+          <a:prstGeom prst="ellipse">
             <a:avLst/>
           </a:prstGeom>
           <a:solidFill>
-            <a:srgbClr val="0B1220"/>
+            <a:srgbClr val="38BDF8"/>
           </a:solidFill>
           <a:ln/>
         </p:spPr>
       </p:sp>
-      <p:sp>
-        <p:nvSpPr>
-          <p:cNvPr id="4" name="Text 1"/>
-          <p:cNvSpPr/>
-          <p:nvPr/>
-        </p:nvSpPr>
-        <p:spPr>
-          <a:xfrm>
-            <a:off x="7269480" y="1463040"/>
-            <a:ext cx="5486400" cy="274320"/>
-          </a:xfrm>
-          <a:prstGeom prst="rect">
-            <a:avLst/>
-          </a:prstGeom>
-          <a:noFill/>
-          <a:ln/>
-        </p:spPr>
-        <p:txBody>
-          <a:bodyPr wrap="square" lIns="0" tIns="0" rIns="0" bIns="0" rtlCol="0" anchor="ctr"/>
-          <a:lstStyle/>
-          <a:p>
-            <a:pPr indent="0" marL="0">
-              <a:buNone/>
-            </a:pPr>
-            <a:r>
-              <a:rPr lang="en-US" sz="1100" b="1" spc="300" kern="0" dirty="0">
-                <a:solidFill>
-                  <a:srgbClr val="38BDF8"/>
-                </a:solidFill>
-                <a:latin typeface="Arial" pitchFamily="34" charset="0"/>
-                <a:ea typeface="Arial" pitchFamily="34" charset="-122"/>
-                <a:cs typeface="Arial" pitchFamily="34" charset="-120"/>
-              </a:rPr>
-              <a:t>AND ONE MORE THING</a:t>
-            </a:r>
-            <a:endParaRPr lang="en-US" sz="1100" dirty="0"/>
-          </a:p>
-        </p:txBody>
-      </p:sp>
-      <p:sp>
-        <p:nvSpPr>
-          <p:cNvPr id="5" name="Text 2"/>
-          <p:cNvSpPr/>
-          <p:nvPr/>
-        </p:nvSpPr>
-        <p:spPr>
-          <a:xfrm>
-            <a:off x="7269480" y="1920240"/>
-            <a:ext cx="4572000" cy="1463040"/>
+      <p:pic>
+        <p:nvPicPr>
+          <p:cNvPr id="5" name="Image 1" descr="/sessions/tender-exciting-mccarthy/mnt/outputs/deck/assets/chiu.jpg">    </p:cNvPr>
+          <p:cNvPicPr>
+            <a:picLocks noChangeAspect="1"/>
+          </p:cNvPicPr>
+          <p:nvPr/>
+        </p:nvPicPr>
+        <p:blipFill>
+          <a:blip r:embed="rId2"/>
+          <a:stretch>
+            <a:fillRect/>
+          </a:stretch>
+        </p:blipFill>
+        <p:spPr>
+          <a:xfrm>
+            <a:off x="7269480" y="1362456"/>
+            <a:ext cx="1463040" cy="1463040"/>
+          </a:xfrm>
+          <a:prstGeom prst="ellipse">
+            <a:avLst/>
+          </a:prstGeom>
+        </p:spPr>
+      </p:pic>
+      <p:sp>
+        <p:nvSpPr>
+          <p:cNvPr id="6" name="Text 2"/>
+          <p:cNvSpPr/>
+          <p:nvPr/>
+        </p:nvSpPr>
+        <p:spPr>
+          <a:xfrm>
+            <a:off x="7269480" y="3154680"/>
+            <a:ext cx="4709160" cy="1005840"/>
           </a:xfrm>
           <a:prstGeom prst="rect">
             <a:avLst/>
@@ -2200,7 +2224,7 @@
               <a:buNone/>
             </a:pPr>
             <a:r>
-              <a:rPr lang="en-US" sz="3200" b="1" dirty="0">
+              <a:rPr lang="en-US" sz="2900" b="1" dirty="0">
                 <a:solidFill>
                   <a:srgbClr val="FFFFFF"/>
                 </a:solidFill>
@@ -2210,19 +2234,19 @@
               </a:rPr>
               <a:t>Signed by its creator.</a:t>
             </a:r>
-            <a:endParaRPr lang="en-US" sz="3200" dirty="0"/>
-          </a:p>
-        </p:txBody>
-      </p:sp>
-      <p:sp>
-        <p:nvSpPr>
-          <p:cNvPr id="6" name="Text 3"/>
-          <p:cNvSpPr/>
-          <p:nvPr/>
-        </p:nvSpPr>
-        <p:spPr>
-          <a:xfrm>
-            <a:off x="7269480" y="3200400"/>
+            <a:endParaRPr lang="en-US" sz="2900" dirty="0"/>
+          </a:p>
+        </p:txBody>
+      </p:sp>
+      <p:sp>
+        <p:nvSpPr>
+          <p:cNvPr id="7" name="Text 3"/>
+          <p:cNvSpPr/>
+          <p:nvPr/>
+        </p:nvSpPr>
+        <p:spPr>
+          <a:xfrm>
+            <a:off x="7269480" y="4251960"/>
             <a:ext cx="4480560" cy="1645920"/>
           </a:xfrm>
           <a:prstGeom prst="rect">
@@ -2328,7 +2352,7 @@
       </p:grpSpPr>
       <p:pic>
         <p:nvPicPr>
-          <p:cNvPr id="2" name="Image 0" descr="/sessions/tender-exciting-mccarthy/mnt/outputs/deck/assets/team_c.jpg">    </p:cNvPr>
+          <p:cNvPr id="2" name="Image 0" descr="/sessions/tender-exciting-mccarthy/mnt/outputs/deck/assets/team_c2.jpg">    </p:cNvPr>
           <p:cNvPicPr>
             <a:picLocks noChangeAspect="1"/>
           </p:cNvPicPr>
@@ -2342,8 +2366,8 @@
         </p:blipFill>
         <p:spPr>
           <a:xfrm>
-            <a:off x="0" y="0"/>
-            <a:ext cx="5852160" cy="6858000"/>
+            <a:off x="457200" y="1325880"/>
+            <a:ext cx="5943600" cy="4434840"/>
           </a:xfrm>
           <a:prstGeom prst="rect">
             <a:avLst/>
@@ -2352,23 +2376,42 @@
       </p:pic>
       <p:sp>
         <p:nvSpPr>
-          <p:cNvPr id="3" name="Shape 0"/>
-          <p:cNvSpPr/>
-          <p:nvPr/>
-        </p:nvSpPr>
-        <p:spPr>
-          <a:xfrm>
-            <a:off x="5852160" y="0"/>
-            <a:ext cx="6336792" cy="6858000"/>
-          </a:xfrm>
-          <a:prstGeom prst="rect">
-            <a:avLst/>
-          </a:prstGeom>
-          <a:solidFill>
-            <a:srgbClr val="0B1220"/>
-          </a:solidFill>
-          <a:ln/>
-        </p:spPr>
+          <p:cNvPr id="3" name="Text 0"/>
+          <p:cNvSpPr/>
+          <p:nvPr/>
+        </p:nvSpPr>
+        <p:spPr>
+          <a:xfrm>
+            <a:off x="457200" y="5852160"/>
+            <a:ext cx="5943600" cy="320040"/>
+          </a:xfrm>
+          <a:prstGeom prst="rect">
+            <a:avLst/>
+          </a:prstGeom>
+          <a:noFill/>
+          <a:ln/>
+        </p:spPr>
+        <p:txBody>
+          <a:bodyPr wrap="square" lIns="0" tIns="0" rIns="0" bIns="0" rtlCol="0" anchor="ctr"/>
+          <a:lstStyle/>
+          <a:p>
+            <a:pPr algn="ctr" indent="0" marL="0">
+              <a:buNone/>
+            </a:pPr>
+            <a:r>
+              <a:rPr lang="en-US" sz="1200" dirty="0">
+                <a:solidFill>
+                  <a:srgbClr val="6B7A90"/>
+                </a:solidFill>
+                <a:latin typeface="Calibri" pitchFamily="34" charset="0"/>
+                <a:ea typeface="Calibri" pitchFamily="34" charset="-122"/>
+                <a:cs typeface="Calibri" pitchFamily="34" charset="-120"/>
+              </a:rPr>
+              <a:t>L→R:  Lukas  ·  Dale  ·  Di</a:t>
+            </a:r>
+            <a:endParaRPr lang="en-US" sz="1200" dirty="0"/>
+          </a:p>
+        </p:txBody>
       </p:sp>
       <p:sp>
         <p:nvSpPr>
@@ -2378,7 +2421,7 @@
         </p:nvSpPr>
         <p:spPr>
           <a:xfrm>
-            <a:off x="6309360" y="594360"/>
+            <a:off x="6720840" y="640080"/>
             <a:ext cx="5486400" cy="274320"/>
           </a:xfrm>
           <a:prstGeom prst="rect">
@@ -2417,8 +2460,8 @@
         </p:nvSpPr>
         <p:spPr>
           <a:xfrm>
-            <a:off x="6309360" y="914400"/>
-            <a:ext cx="5486400" cy="640080"/>
+            <a:off x="6720840" y="960120"/>
+            <a:ext cx="5120640" cy="640080"/>
           </a:xfrm>
           <a:prstGeom prst="rect">
             <a:avLst/>
@@ -2456,12 +2499,12 @@
         </p:nvSpPr>
         <p:spPr>
           <a:xfrm>
-            <a:off x="6309360" y="1691640"/>
-            <a:ext cx="5440680" cy="1051560"/>
+            <a:off x="6720840" y="1783080"/>
+            <a:ext cx="5074920" cy="1097280"/>
           </a:xfrm>
           <a:prstGeom prst="roundRect">
             <a:avLst>
-              <a:gd name="adj" fmla="val 8696"/>
+              <a:gd name="adj" fmla="val 8333"/>
             </a:avLst>
           </a:prstGeom>
           <a:solidFill>
@@ -2483,8 +2526,8 @@
         </p:nvSpPr>
         <p:spPr>
           <a:xfrm>
-            <a:off x="6583680" y="1810512"/>
-            <a:ext cx="4937760" cy="365760"/>
+            <a:off x="6995160" y="1920240"/>
+            <a:ext cx="4572000" cy="365760"/>
           </a:xfrm>
           <a:prstGeom prst="rect">
             <a:avLst/>
@@ -2508,7 +2551,7 @@
                 <a:ea typeface="Arial" pitchFamily="34" charset="-122"/>
                 <a:cs typeface="Arial" pitchFamily="34" charset="-120"/>
               </a:rPr>
-              <a:t>Dale Herzog</a:t>
+              <a:t>Lukas Bromig</a:t>
             </a:r>
             <a:endParaRPr lang="en-US" sz="1700" dirty="0"/>
           </a:p>
@@ -2522,8 +2565,8 @@
         </p:nvSpPr>
         <p:spPr>
           <a:xfrm>
-            <a:off x="6583680" y="2148840"/>
-            <a:ext cx="4937760" cy="320040"/>
+            <a:off x="6995160" y="2267712"/>
+            <a:ext cx="4572000" cy="320040"/>
           </a:xfrm>
           <a:prstGeom prst="rect">
             <a:avLst/>
@@ -2547,7 +2590,7 @@
                 <a:ea typeface="Arial" pitchFamily="34" charset="-122"/>
                 <a:cs typeface="Arial" pitchFamily="34" charset="-120"/>
               </a:rPr>
-              <a:t>Manipulation &amp; end-effectors</a:t>
+              <a:t>Liquid handler &amp; orchestration</a:t>
             </a:r>
             <a:endParaRPr lang="en-US" sz="1300" dirty="0"/>
           </a:p>
@@ -2561,8 +2604,8 @@
         </p:nvSpPr>
         <p:spPr>
           <a:xfrm>
-            <a:off x="6583680" y="2423160"/>
-            <a:ext cx="4937760" cy="274320"/>
+            <a:off x="6995160" y="2551176"/>
+            <a:ext cx="4572000" cy="274320"/>
           </a:xfrm>
           <a:prstGeom prst="rect">
             <a:avLst/>
@@ -2586,7 +2629,7 @@
                 <a:ea typeface="Calibri" pitchFamily="34" charset="-122"/>
                 <a:cs typeface="Calibri" pitchFamily="34" charset="-120"/>
               </a:rPr>
-              <a:t>CAD modeler · coffee nerd</a:t>
+              <a:t>co-founder, UniteLabs</a:t>
             </a:r>
             <a:endParaRPr lang="en-US" sz="1200" dirty="0"/>
           </a:p>
@@ -2600,12 +2643,12 @@
         </p:nvSpPr>
         <p:spPr>
           <a:xfrm>
-            <a:off x="6309360" y="2926080"/>
-            <a:ext cx="5440680" cy="1051560"/>
+            <a:off x="6720840" y="3063240"/>
+            <a:ext cx="5074920" cy="1097280"/>
           </a:xfrm>
           <a:prstGeom prst="roundRect">
             <a:avLst>
-              <a:gd name="adj" fmla="val 8696"/>
+              <a:gd name="adj" fmla="val 8333"/>
             </a:avLst>
           </a:prstGeom>
           <a:solidFill>
@@ -2627,8 +2670,8 @@
         </p:nvSpPr>
         <p:spPr>
           <a:xfrm>
-            <a:off x="6583680" y="3044952"/>
-            <a:ext cx="4937760" cy="365760"/>
+            <a:off x="6995160" y="3200400"/>
+            <a:ext cx="4572000" cy="365760"/>
           </a:xfrm>
           <a:prstGeom prst="rect">
             <a:avLst/>
@@ -2652,7 +2695,7 @@
                 <a:ea typeface="Arial" pitchFamily="34" charset="-122"/>
                 <a:cs typeface="Arial" pitchFamily="34" charset="-120"/>
               </a:rPr>
-              <a:t>Di Hu</a:t>
+              <a:t>Dale Herzog</a:t>
             </a:r>
             <a:endParaRPr lang="en-US" sz="1700" dirty="0"/>
           </a:p>
@@ -2666,8 +2709,8 @@
         </p:nvSpPr>
         <p:spPr>
           <a:xfrm>
-            <a:off x="6583680" y="3383280"/>
-            <a:ext cx="4937760" cy="320040"/>
+            <a:off x="6995160" y="3547872"/>
+            <a:ext cx="4572000" cy="320040"/>
           </a:xfrm>
           <a:prstGeom prst="rect">
             <a:avLst/>
@@ -2691,7 +2734,7 @@
                 <a:ea typeface="Arial" pitchFamily="34" charset="-122"/>
                 <a:cs typeface="Arial" pitchFamily="34" charset="-120"/>
               </a:rPr>
-              <a:t>Perception &amp; AI verification</a:t>
+              <a:t>Arm — dual xArm &amp; end-effectors</a:t>
             </a:r>
             <a:endParaRPr lang="en-US" sz="1300" dirty="0"/>
           </a:p>
@@ -2705,8 +2748,8 @@
         </p:nvSpPr>
         <p:spPr>
           <a:xfrm>
-            <a:off x="6583680" y="3657600"/>
-            <a:ext cx="4937760" cy="274320"/>
+            <a:off x="6995160" y="3831336"/>
+            <a:ext cx="4572000" cy="274320"/>
           </a:xfrm>
           <a:prstGeom prst="rect">
             <a:avLst/>
@@ -2730,7 +2773,7 @@
                 <a:ea typeface="Calibri" pitchFamily="34" charset="-122"/>
                 <a:cs typeface="Calibri" pitchFamily="34" charset="-120"/>
               </a:rPr>
-              <a:t>bench scientist gone full AI×automation</a:t>
+              <a:t>CAD modeler · coffee nerd</a:t>
             </a:r>
             <a:endParaRPr lang="en-US" sz="1200" dirty="0"/>
           </a:p>
@@ -2744,12 +2787,12 @@
         </p:nvSpPr>
         <p:spPr>
           <a:xfrm>
-            <a:off x="6309360" y="4160520"/>
-            <a:ext cx="5440680" cy="1051560"/>
+            <a:off x="6720840" y="4343400"/>
+            <a:ext cx="5074920" cy="1097280"/>
           </a:xfrm>
           <a:prstGeom prst="roundRect">
             <a:avLst>
-              <a:gd name="adj" fmla="val 8696"/>
+              <a:gd name="adj" fmla="val 8333"/>
             </a:avLst>
           </a:prstGeom>
           <a:solidFill>
@@ -2771,8 +2814,8 @@
         </p:nvSpPr>
         <p:spPr>
           <a:xfrm>
-            <a:off x="6583680" y="4279392"/>
-            <a:ext cx="4937760" cy="365760"/>
+            <a:off x="6995160" y="4480560"/>
+            <a:ext cx="4572000" cy="365760"/>
           </a:xfrm>
           <a:prstGeom prst="rect">
             <a:avLst/>
@@ -2796,7 +2839,7 @@
                 <a:ea typeface="Arial" pitchFamily="34" charset="-122"/>
                 <a:cs typeface="Arial" pitchFamily="34" charset="-120"/>
               </a:rPr>
-              <a:t>Lukas Bromig</a:t>
+              <a:t>Di Hu</a:t>
             </a:r>
             <a:endParaRPr lang="en-US" sz="1700" dirty="0"/>
           </a:p>
@@ -2810,8 +2853,8 @@
         </p:nvSpPr>
         <p:spPr>
           <a:xfrm>
-            <a:off x="6583680" y="4617720"/>
-            <a:ext cx="4937760" cy="320040"/>
+            <a:off x="6995160" y="4828032"/>
+            <a:ext cx="4572000" cy="320040"/>
           </a:xfrm>
           <a:prstGeom prst="rect">
             <a:avLst/>
@@ -2835,7 +2878,7 @@
                 <a:ea typeface="Arial" pitchFamily="34" charset="-122"/>
                 <a:cs typeface="Arial" pitchFamily="34" charset="-120"/>
               </a:rPr>
-              <a:t>Integration &amp; orchestration</a:t>
+              <a:t>Camera — perception &amp; AI verify</a:t>
             </a:r>
             <a:endParaRPr lang="en-US" sz="1300" dirty="0"/>
           </a:p>
@@ -2849,8 +2892,8 @@
         </p:nvSpPr>
         <p:spPr>
           <a:xfrm>
-            <a:off x="6583680" y="4892040"/>
-            <a:ext cx="4937760" cy="274320"/>
+            <a:off x="6995160" y="5111496"/>
+            <a:ext cx="4572000" cy="274320"/>
           </a:xfrm>
           <a:prstGeom prst="rect">
             <a:avLst/>
@@ -2874,7 +2917,7 @@
                 <a:ea typeface="Calibri" pitchFamily="34" charset="-122"/>
                 <a:cs typeface="Calibri" pitchFamily="34" charset="-120"/>
               </a:rPr>
-              <a:t>co-founder, UniteLabs</a:t>
+              <a:t>bench scientist → AI×automation</a:t>
             </a:r>
             <a:endParaRPr lang="en-US" sz="1200" dirty="0"/>
           </a:p>
@@ -2888,8 +2931,8 @@
         </p:nvSpPr>
         <p:spPr>
           <a:xfrm>
-            <a:off x="6309360" y="5806440"/>
-            <a:ext cx="5440680" cy="548640"/>
+            <a:off x="6720840" y="5897880"/>
+            <a:ext cx="5074920" cy="548640"/>
           </a:xfrm>
           <a:prstGeom prst="rect">
             <a:avLst/>
@@ -2908,7 +2951,7 @@
               <a:buNone/>
             </a:pPr>
             <a:r>
-              <a:rPr lang="en-US" sz="1250" dirty="0">
+              <a:rPr lang="en-US" sz="1200" dirty="0">
                 <a:solidFill>
                   <a:srgbClr val="8291AC"/>
                 </a:solidFill>
@@ -2918,7 +2961,7 @@
               </a:rPr>
               <a:t>The verify-loop generalizes to any step or instrument.   ·   github.com/Lbromig/hackathon-zeon</a:t>
             </a:r>
-            <a:endParaRPr lang="en-US" sz="1250" dirty="0"/>
+            <a:endParaRPr lang="en-US" sz="1200" dirty="0"/>
           </a:p>
         </p:txBody>
       </p:sp>

</xml_diff>